<commit_message>
Small updates to the wording, and fix level 2 ordering rule
</commit_message>
<xml_diff>
--- a/Week09-10/C2_slides/Lab5_2.pptx
+++ b/Week09-10/C2_slides/Lab5_2.pptx
@@ -5,7 +5,7 @@
     <p:sldMasterId id="2147483678" r:id="rId1"/>
   </p:sldMasterIdLst>
   <p:notesMasterIdLst>
-    <p:notesMasterId r:id="rId10"/>
+    <p:notesMasterId r:id="rId13"/>
   </p:notesMasterIdLst>
   <p:sldIdLst>
     <p:sldId id="299" r:id="rId2"/>
@@ -14,8 +14,11 @@
     <p:sldId id="305" r:id="rId5"/>
     <p:sldId id="265" r:id="rId6"/>
     <p:sldId id="300" r:id="rId7"/>
-    <p:sldId id="301" r:id="rId8"/>
-    <p:sldId id="304" r:id="rId9"/>
+    <p:sldId id="309" r:id="rId8"/>
+    <p:sldId id="310" r:id="rId9"/>
+    <p:sldId id="311" r:id="rId10"/>
+    <p:sldId id="304" r:id="rId11"/>
+    <p:sldId id="307" r:id="rId12"/>
   </p:sldIdLst>
   <p:sldSz cx="12192000" cy="6858000"/>
   <p:notesSz cx="6858000" cy="9144000"/>
@@ -248,7 +251,7 @@
           <a:p>
             <a:fld id="{A9407A57-47BC-45C1-B9EB-906F4463B0AB}" type="datetimeFigureOut">
               <a:rPr lang="en-AU" smtClean="0"/>
-              <a:t>22/09/2025</a:t>
+              <a:t>7/10/2025</a:t>
             </a:fld>
             <a:endParaRPr lang="en-AU"/>
           </a:p>
@@ -684,7 +687,7 @@
           <a:p>
             <a:fld id="{1205BC88-DBF0-4610-A802-A09E0A6ECD22}" type="datetimeFigureOut">
               <a:rPr lang="en-AU" smtClean="0"/>
-              <a:t>22/09/2025</a:t>
+              <a:t>7/10/2025</a:t>
             </a:fld>
             <a:endParaRPr lang="en-AU"/>
           </a:p>
@@ -919,7 +922,7 @@
           <a:p>
             <a:fld id="{1205BC88-DBF0-4610-A802-A09E0A6ECD22}" type="datetimeFigureOut">
               <a:rPr lang="en-AU" smtClean="0"/>
-              <a:t>22/09/2025</a:t>
+              <a:t>7/10/2025</a:t>
             </a:fld>
             <a:endParaRPr lang="en-AU"/>
           </a:p>
@@ -1099,7 +1102,7 @@
           <a:p>
             <a:fld id="{1205BC88-DBF0-4610-A802-A09E0A6ECD22}" type="datetimeFigureOut">
               <a:rPr lang="en-AU" smtClean="0"/>
-              <a:t>22/09/2025</a:t>
+              <a:t>7/10/2025</a:t>
             </a:fld>
             <a:endParaRPr lang="en-AU"/>
           </a:p>
@@ -1269,7 +1272,7 @@
           <a:p>
             <a:fld id="{1205BC88-DBF0-4610-A802-A09E0A6ECD22}" type="datetimeFigureOut">
               <a:rPr lang="en-AU" smtClean="0"/>
-              <a:t>22/09/2025</a:t>
+              <a:t>7/10/2025</a:t>
             </a:fld>
             <a:endParaRPr lang="en-AU"/>
           </a:p>
@@ -1523,7 +1526,7 @@
           <a:p>
             <a:fld id="{1205BC88-DBF0-4610-A802-A09E0A6ECD22}" type="datetimeFigureOut">
               <a:rPr lang="en-AU" smtClean="0"/>
-              <a:t>22/09/2025</a:t>
+              <a:t>7/10/2025</a:t>
             </a:fld>
             <a:endParaRPr lang="en-AU"/>
           </a:p>
@@ -1849,7 +1852,7 @@
           <a:p>
             <a:fld id="{1205BC88-DBF0-4610-A802-A09E0A6ECD22}" type="datetimeFigureOut">
               <a:rPr lang="en-AU" smtClean="0"/>
-              <a:t>22/09/2025</a:t>
+              <a:t>7/10/2025</a:t>
             </a:fld>
             <a:endParaRPr lang="en-AU"/>
           </a:p>
@@ -2300,7 +2303,7 @@
           <a:p>
             <a:fld id="{1205BC88-DBF0-4610-A802-A09E0A6ECD22}" type="datetimeFigureOut">
               <a:rPr lang="en-AU" smtClean="0"/>
-              <a:t>22/09/2025</a:t>
+              <a:t>7/10/2025</a:t>
             </a:fld>
             <a:endParaRPr lang="en-AU"/>
           </a:p>
@@ -2418,7 +2421,7 @@
           <a:p>
             <a:fld id="{1205BC88-DBF0-4610-A802-A09E0A6ECD22}" type="datetimeFigureOut">
               <a:rPr lang="en-AU" smtClean="0"/>
-              <a:t>22/09/2025</a:t>
+              <a:t>7/10/2025</a:t>
             </a:fld>
             <a:endParaRPr lang="en-AU"/>
           </a:p>
@@ -2513,7 +2516,7 @@
           <a:p>
             <a:fld id="{1205BC88-DBF0-4610-A802-A09E0A6ECD22}" type="datetimeFigureOut">
               <a:rPr lang="en-AU" smtClean="0"/>
-              <a:t>22/09/2025</a:t>
+              <a:t>7/10/2025</a:t>
             </a:fld>
             <a:endParaRPr lang="en-AU"/>
           </a:p>
@@ -2800,7 +2803,7 @@
           <a:p>
             <a:fld id="{1205BC88-DBF0-4610-A802-A09E0A6ECD22}" type="datetimeFigureOut">
               <a:rPr lang="en-AU" smtClean="0"/>
-              <a:t>22/09/2025</a:t>
+              <a:t>7/10/2025</a:t>
             </a:fld>
             <a:endParaRPr lang="en-AU"/>
           </a:p>
@@ -3122,7 +3125,7 @@
           <a:p>
             <a:fld id="{1205BC88-DBF0-4610-A802-A09E0A6ECD22}" type="datetimeFigureOut">
               <a:rPr lang="en-AU" smtClean="0"/>
-              <a:t>22/09/2025</a:t>
+              <a:t>7/10/2025</a:t>
             </a:fld>
             <a:endParaRPr lang="en-AU"/>
           </a:p>
@@ -3383,7 +3386,7 @@
           <a:p>
             <a:fld id="{1205BC88-DBF0-4610-A802-A09E0A6ECD22}" type="datetimeFigureOut">
               <a:rPr lang="en-AU" smtClean="0"/>
-              <a:t>22/09/2025</a:t>
+              <a:t>7/10/2025</a:t>
             </a:fld>
             <a:endParaRPr lang="en-AU"/>
           </a:p>
@@ -4104,6 +4107,886 @@
 </p:sld>
 </file>
 
+<file path=ppt/slides/slide10.xml><?xml version="1.0" encoding="utf-8"?>
+<p:sld xmlns:a="http://schemas.openxmlformats.org/drawingml/2006/main" xmlns:r="http://schemas.openxmlformats.org/officeDocument/2006/relationships" xmlns:p="http://schemas.openxmlformats.org/presentationml/2006/main">
+  <p:cSld>
+    <p:spTree>
+      <p:nvGrpSpPr>
+        <p:cNvPr id="1" name=""/>
+        <p:cNvGrpSpPr/>
+        <p:nvPr/>
+      </p:nvGrpSpPr>
+      <p:grpSpPr>
+        <a:xfrm>
+          <a:off x="0" y="0"/>
+          <a:ext cx="0" cy="0"/>
+          <a:chOff x="0" y="0"/>
+          <a:chExt cx="0" cy="0"/>
+        </a:xfrm>
+      </p:grpSpPr>
+      <p:sp>
+        <p:nvSpPr>
+          <p:cNvPr id="50" name="TextBox 49">
+            <a:extLst>
+              <a:ext uri="{FF2B5EF4-FFF2-40B4-BE49-F238E27FC236}">
+                <a16:creationId xmlns:a16="http://schemas.microsoft.com/office/drawing/2014/main" id="{BF948A99-782B-4139-A61F-6C2663DAEB76}"/>
+              </a:ext>
+            </a:extLst>
+          </p:cNvPr>
+          <p:cNvSpPr txBox="1"/>
+          <p:nvPr/>
+        </p:nvSpPr>
+        <p:spPr>
+          <a:xfrm>
+            <a:off x="478180" y="7379"/>
+            <a:ext cx="11713820" cy="830997"/>
+          </a:xfrm>
+          <a:prstGeom prst="rect">
+            <a:avLst/>
+          </a:prstGeom>
+          <a:noFill/>
+        </p:spPr>
+        <p:txBody>
+          <a:bodyPr wrap="square" rtlCol="0">
+            <a:spAutoFit/>
+          </a:bodyPr>
+          <a:lstStyle/>
+          <a:p>
+            <a:pPr algn="ctr"/>
+            <a:r>
+              <a:rPr lang="en-AU" sz="4800" dirty="0"/>
+              <a:t>Final Demo: Mapping</a:t>
+            </a:r>
+          </a:p>
+        </p:txBody>
+      </p:sp>
+      <mc:AlternateContent xmlns:mc="http://schemas.openxmlformats.org/markup-compatibility/2006" xmlns:a14="http://schemas.microsoft.com/office/drawing/2010/main">
+        <mc:Choice Requires="a14">
+          <p:sp>
+            <p:nvSpPr>
+              <p:cNvPr id="5" name="TextBox 4">
+                <a:extLst>
+                  <a:ext uri="{FF2B5EF4-FFF2-40B4-BE49-F238E27FC236}">
+                    <a16:creationId xmlns:a16="http://schemas.microsoft.com/office/drawing/2014/main" id="{777CEF6B-BB09-4C7B-EDC5-D0D9FC6E13C5}"/>
+                  </a:ext>
+                </a:extLst>
+              </p:cNvPr>
+              <p:cNvSpPr txBox="1"/>
+              <p:nvPr/>
+            </p:nvSpPr>
+            <p:spPr>
+              <a:xfrm>
+                <a:off x="478180" y="838376"/>
+                <a:ext cx="11588314" cy="7365093"/>
+              </a:xfrm>
+              <a:prstGeom prst="rect">
+                <a:avLst/>
+              </a:prstGeom>
+              <a:noFill/>
+            </p:spPr>
+            <p:txBody>
+              <a:bodyPr wrap="square" rtlCol="0">
+                <a:spAutoFit/>
+              </a:bodyPr>
+              <a:lstStyle/>
+              <a:p>
+                <a:endParaRPr lang="en-US" sz="1600" dirty="0"/>
+              </a:p>
+              <a:p>
+                <a:r>
+                  <a:rPr lang="en-US" sz="1600" dirty="0"/>
+                  <a:t>Mapping (30 points):</a:t>
+                </a:r>
+              </a:p>
+              <a:p>
+                <a:r>
+                  <a:rPr lang="en-US" sz="1600" dirty="0"/>
+                  <a:t>	</a:t>
+                </a:r>
+                <a:r>
+                  <a:rPr lang="en-US" sz="1600" dirty="0" err="1"/>
+                  <a:t>ArUco</a:t>
+                </a:r>
+                <a:r>
+                  <a:rPr lang="en-US" sz="1600" dirty="0"/>
+                  <a:t> slam map (0 ≤ </a:t>
+                </a:r>
+                <a:r>
+                  <a:rPr lang="en-US" sz="1600" dirty="0" err="1"/>
+                  <a:t>slam_score</a:t>
+                </a:r>
+                <a:r>
+                  <a:rPr lang="en-US" sz="1600" dirty="0"/>
+                  <a:t> ≤ 15pt): </a:t>
+                </a:r>
+              </a:p>
+              <a:p>
+                <a:endParaRPr lang="en-US" sz="1600" dirty="0"/>
+              </a:p>
+              <a:p>
+                <a:endParaRPr lang="en-US" sz="1600" dirty="0"/>
+              </a:p>
+              <a:p>
+                <a:r>
+                  <a:rPr lang="en-US" sz="1600" dirty="0"/>
+                  <a:t>	</a:t>
+                </a:r>
+              </a:p>
+              <a:p>
+                <a:r>
+                  <a:rPr lang="en-US" sz="1600" dirty="0"/>
+                  <a:t>Target map (0 ≤ </a:t>
+                </a:r>
+                <a:r>
+                  <a:rPr lang="en-US" sz="1600" dirty="0" err="1"/>
+                  <a:t>target_est_score</a:t>
+                </a:r>
+                <a:r>
+                  <a:rPr lang="en-US" sz="1600" dirty="0"/>
+                  <a:t> ≤ 15pt):</a:t>
+                </a:r>
+              </a:p>
+              <a:p>
+                <a:pPr algn="ctr"/>
+                <a:r>
+                  <a:rPr lang="en-US" sz="1600" dirty="0"/>
+                  <a:t>	</a:t>
+                </a:r>
+                <a:r>
+                  <a:rPr lang="en-GB" sz="1600" dirty="0">
+                    <a:solidFill>
+                      <a:srgbClr val="FFFF00"/>
+                    </a:solidFill>
+                  </a:rPr>
+                  <a:t> </a:t>
+                </a:r>
+                <a:r>
+                  <a:rPr lang="en-GB" sz="1600" dirty="0">
+                    <a:solidFill>
+                      <a:schemeClr val="tx1"/>
+                    </a:solidFill>
+                  </a:rPr>
+                  <a:t>target_accuracy_rating[object] = </a:t>
+                </a:r>
+                <a14:m>
+                  <m:oMath xmlns:m="http://schemas.openxmlformats.org/officeDocument/2006/math">
+                    <m:f>
+                      <m:fPr>
+                        <m:ctrlPr>
+                          <a:rPr lang="en-GB" sz="1600" i="1" dirty="0" smtClean="0">
+                            <a:solidFill>
+                              <a:schemeClr val="tx1"/>
+                            </a:solidFill>
+                            <a:latin typeface="Cambria Math" panose="02040503050406030204" pitchFamily="18" charset="0"/>
+                          </a:rPr>
+                        </m:ctrlPr>
+                      </m:fPr>
+                      <m:num>
+                        <m:r>
+                          <a:rPr lang="en-GB" sz="1600" i="1" dirty="0" smtClean="0">
+                            <a:solidFill>
+                              <a:schemeClr val="tx1"/>
+                            </a:solidFill>
+                            <a:latin typeface="Cambria Math" panose="02040503050406030204" pitchFamily="18" charset="0"/>
+                          </a:rPr>
+                          <m:t>0.5 − </m:t>
+                        </m:r>
+                        <m:r>
+                          <a:rPr lang="en-GB" sz="1600" i="1" dirty="0" err="1">
+                            <a:solidFill>
+                              <a:schemeClr val="tx1"/>
+                            </a:solidFill>
+                            <a:latin typeface="Cambria Math" panose="02040503050406030204" pitchFamily="18" charset="0"/>
+                          </a:rPr>
+                          <m:t>𝑒𝑠𝑡𝑖𝑚𝑎𝑡𝑖𝑜𝑛</m:t>
+                        </m:r>
+                        <m:r>
+                          <a:rPr lang="en-AU" sz="1600" b="0" i="1" dirty="0" smtClean="0">
+                            <a:solidFill>
+                              <a:schemeClr val="tx1"/>
+                            </a:solidFill>
+                            <a:latin typeface="Cambria Math" panose="02040503050406030204" pitchFamily="18" charset="0"/>
+                          </a:rPr>
+                          <m:t>_</m:t>
+                        </m:r>
+                        <m:r>
+                          <a:rPr lang="en-GB" sz="1600" i="1" dirty="0" err="1">
+                            <a:solidFill>
+                              <a:schemeClr val="tx1"/>
+                            </a:solidFill>
+                            <a:latin typeface="Cambria Math" panose="02040503050406030204" pitchFamily="18" charset="0"/>
+                          </a:rPr>
+                          <m:t>𝑒𝑟𝑟𝑜𝑟</m:t>
+                        </m:r>
+                        <m:d>
+                          <m:dPr>
+                            <m:begChr m:val="["/>
+                            <m:endChr m:val="]"/>
+                            <m:ctrlPr>
+                              <a:rPr lang="en-GB" sz="1600" i="1" dirty="0">
+                                <a:solidFill>
+                                  <a:schemeClr val="tx1"/>
+                                </a:solidFill>
+                                <a:latin typeface="Cambria Math" panose="02040503050406030204" pitchFamily="18" charset="0"/>
+                              </a:rPr>
+                            </m:ctrlPr>
+                          </m:dPr>
+                          <m:e>
+                            <m:r>
+                              <a:rPr lang="en-GB" sz="1600" i="1" dirty="0">
+                                <a:solidFill>
+                                  <a:schemeClr val="tx1"/>
+                                </a:solidFill>
+                                <a:latin typeface="Cambria Math" panose="02040503050406030204" pitchFamily="18" charset="0"/>
+                              </a:rPr>
+                              <m:t>𝑜𝑏𝑗𝑒𝑐𝑡</m:t>
+                            </m:r>
+                          </m:e>
+                        </m:d>
+                      </m:num>
+                      <m:den>
+                        <m:r>
+                          <a:rPr lang="en-GB" sz="1600" i="1" dirty="0">
+                            <a:solidFill>
+                              <a:schemeClr val="tx1"/>
+                            </a:solidFill>
+                            <a:latin typeface="Cambria Math" panose="02040503050406030204" pitchFamily="18" charset="0"/>
+                          </a:rPr>
+                          <m:t>0.5−0.025</m:t>
+                        </m:r>
+                      </m:den>
+                    </m:f>
+                    <m:r>
+                      <a:rPr lang="en-GB" sz="1600" i="1" dirty="0" smtClean="0">
+                        <a:solidFill>
+                          <a:schemeClr val="tx1"/>
+                        </a:solidFill>
+                        <a:latin typeface="Cambria Math" panose="02040503050406030204" pitchFamily="18" charset="0"/>
+                      </a:rPr>
+                      <m:t> </m:t>
+                    </m:r>
+                  </m:oMath>
+                </a14:m>
+                <a:r>
+                  <a:rPr lang="en-GB" sz="1600" dirty="0">
+                    <a:solidFill>
+                      <a:schemeClr val="tx1"/>
+                    </a:solidFill>
+                  </a:rPr>
+                  <a:t>= TAR</a:t>
+                </a:r>
+                <a:r>
+                  <a:rPr lang="en-GB" sz="1600" dirty="0">
+                    <a:solidFill>
+                      <a:srgbClr val="FFFF00"/>
+                    </a:solidFill>
+                  </a:rPr>
+                  <a:t>	</a:t>
+                </a:r>
+              </a:p>
+              <a:p>
+                <a:pPr algn="ctr"/>
+                <a:r>
+                  <a:rPr lang="en-GB" sz="1600" dirty="0" err="1">
+                    <a:solidFill>
+                      <a:schemeClr val="tx1"/>
+                    </a:solidFill>
+                  </a:rPr>
+                  <a:t>target_est_score</a:t>
+                </a:r>
+                <a:r>
+                  <a:rPr lang="en-GB" sz="1600" dirty="0">
+                    <a:solidFill>
+                      <a:schemeClr val="tx1"/>
+                    </a:solidFill>
+                  </a:rPr>
+                  <a:t> = </a:t>
+                </a:r>
+                <a14:m>
+                  <m:oMath xmlns:m="http://schemas.openxmlformats.org/officeDocument/2006/math">
+                    <m:f>
+                      <m:fPr>
+                        <m:ctrlPr>
+                          <a:rPr lang="en-GB" sz="1600" i="1" dirty="0">
+                            <a:solidFill>
+                              <a:schemeClr val="tx1"/>
+                            </a:solidFill>
+                            <a:latin typeface="Cambria Math" panose="02040503050406030204" pitchFamily="18" charset="0"/>
+                          </a:rPr>
+                        </m:ctrlPr>
+                      </m:fPr>
+                      <m:num>
+                        <m:r>
+                          <a:rPr lang="en-GB" sz="1600" i="1" dirty="0" err="1">
+                            <a:solidFill>
+                              <a:schemeClr val="tx1"/>
+                            </a:solidFill>
+                            <a:latin typeface="Cambria Math" panose="02040503050406030204" pitchFamily="18" charset="0"/>
+                          </a:rPr>
+                          <m:t>𝑏𝑎𝑠</m:t>
+                        </m:r>
+                        <m:sSup>
+                          <m:sSupPr>
+                            <m:ctrlPr>
+                              <a:rPr lang="en-GB" sz="1600" i="1" dirty="0" err="1">
+                                <a:solidFill>
+                                  <a:schemeClr val="tx1"/>
+                                </a:solidFill>
+                                <a:latin typeface="Cambria Math" panose="02040503050406030204" pitchFamily="18" charset="0"/>
+                              </a:rPr>
+                            </m:ctrlPr>
+                          </m:sSupPr>
+                          <m:e>
+                            <m:r>
+                              <a:rPr lang="en-GB" sz="1600" i="1" dirty="0" err="1">
+                                <a:solidFill>
+                                  <a:schemeClr val="tx1"/>
+                                </a:solidFill>
+                                <a:latin typeface="Cambria Math" panose="02040503050406030204" pitchFamily="18" charset="0"/>
+                              </a:rPr>
+                              <m:t>𝑒</m:t>
+                            </m:r>
+                          </m:e>
+                          <m:sup>
+                            <m:r>
+                              <a:rPr lang="en-GB" sz="1600" i="1" dirty="0" err="1">
+                                <a:solidFill>
+                                  <a:schemeClr val="tx1"/>
+                                </a:solidFill>
+                                <a:latin typeface="Cambria Math" panose="02040503050406030204" pitchFamily="18" charset="0"/>
+                              </a:rPr>
+                              <m:t>𝑚𝑒𝑎𝑛</m:t>
+                            </m:r>
+                            <m:d>
+                              <m:dPr>
+                                <m:ctrlPr>
+                                  <a:rPr lang="en-GB" sz="1600" i="1" dirty="0">
+                                    <a:solidFill>
+                                      <a:schemeClr val="tx1"/>
+                                    </a:solidFill>
+                                    <a:latin typeface="Cambria Math" panose="02040503050406030204" pitchFamily="18" charset="0"/>
+                                  </a:rPr>
+                                </m:ctrlPr>
+                              </m:dPr>
+                              <m:e>
+                                <m:r>
+                                  <a:rPr lang="en-GB" sz="1600" i="1" dirty="0">
+                                    <a:solidFill>
+                                      <a:schemeClr val="tx1"/>
+                                    </a:solidFill>
+                                    <a:latin typeface="Cambria Math" panose="02040503050406030204" pitchFamily="18" charset="0"/>
+                                  </a:rPr>
+                                  <m:t>𝑇𝐴𝑅</m:t>
+                                </m:r>
+                              </m:e>
+                            </m:d>
+                          </m:sup>
+                        </m:sSup>
+                        <m:r>
+                          <a:rPr lang="en-GB" sz="1600" i="1" dirty="0">
+                            <a:solidFill>
+                              <a:schemeClr val="tx1"/>
+                            </a:solidFill>
+                            <a:latin typeface="Cambria Math" panose="02040503050406030204" pitchFamily="18" charset="0"/>
+                          </a:rPr>
+                          <m:t>– 1</m:t>
+                        </m:r>
+                      </m:num>
+                      <m:den>
+                        <m:r>
+                          <a:rPr lang="en-GB" sz="1600" i="1" dirty="0">
+                            <a:solidFill>
+                              <a:schemeClr val="tx1"/>
+                            </a:solidFill>
+                            <a:latin typeface="Cambria Math" panose="02040503050406030204" pitchFamily="18" charset="0"/>
+                          </a:rPr>
+                          <m:t>𝑏𝑎𝑠𝑒</m:t>
+                        </m:r>
+                        <m:r>
+                          <a:rPr lang="en-GB" sz="1600" i="1" dirty="0">
+                            <a:solidFill>
+                              <a:schemeClr val="tx1"/>
+                            </a:solidFill>
+                            <a:latin typeface="Cambria Math" panose="02040503050406030204" pitchFamily="18" charset="0"/>
+                          </a:rPr>
+                          <m:t> – 1</m:t>
+                        </m:r>
+                      </m:den>
+                    </m:f>
+                    <m:r>
+                      <a:rPr lang="en-GB" sz="1600" i="1" dirty="0">
+                        <a:solidFill>
+                          <a:schemeClr val="tx1"/>
+                        </a:solidFill>
+                        <a:latin typeface="Cambria Math" panose="02040503050406030204" pitchFamily="18" charset="0"/>
+                      </a:rPr>
+                      <m:t> ∗</m:t>
+                    </m:r>
+                    <m:r>
+                      <a:rPr lang="en-AU" sz="1600" b="0" i="1" dirty="0" smtClean="0">
+                        <a:solidFill>
+                          <a:schemeClr val="tx1"/>
+                        </a:solidFill>
+                        <a:latin typeface="Cambria Math" panose="02040503050406030204" pitchFamily="18" charset="0"/>
+                      </a:rPr>
+                      <m:t>15</m:t>
+                    </m:r>
+                  </m:oMath>
+                </a14:m>
+                <a:r>
+                  <a:rPr lang="en-GB" sz="1600" dirty="0">
+                    <a:solidFill>
+                      <a:schemeClr val="tx1"/>
+                    </a:solidFill>
+                  </a:rPr>
+                  <a:t>, base = 8</a:t>
+                </a:r>
+              </a:p>
+              <a:p>
+                <a:pPr algn="ctr"/>
+                <a:endParaRPr lang="en-GB" sz="1600" dirty="0">
+                  <a:solidFill>
+                    <a:schemeClr val="tx1"/>
+                  </a:solidFill>
+                </a:endParaRPr>
+              </a:p>
+              <a:p>
+                <a:r>
+                  <a:rPr lang="en-GB" sz="1600" dirty="0">
+                    <a:solidFill>
+                      <a:schemeClr val="tx1"/>
+                    </a:solidFill>
+                  </a:rPr>
+                  <a:t>Example submission folder structure format (Please read the marking instructions </a:t>
+                </a:r>
+                <a:r>
+                  <a:rPr lang="en-GB" sz="1600">
+                    <a:solidFill>
+                      <a:schemeClr val="tx1"/>
+                    </a:solidFill>
+                  </a:rPr>
+                  <a:t>carefully for this!):</a:t>
+                </a:r>
+                <a:endParaRPr lang="en-GB" sz="1600" dirty="0">
+                  <a:solidFill>
+                    <a:schemeClr val="tx1"/>
+                  </a:solidFill>
+                </a:endParaRPr>
+              </a:p>
+              <a:p>
+                <a:r>
+                  <a:rPr lang="en-AU" dirty="0"/>
+                  <a:t>.</a:t>
+                </a:r>
+              </a:p>
+              <a:p>
+                <a:r>
+                  <a:rPr lang="en-AU" dirty="0"/>
+                  <a:t>├── C2_Team_X0</a:t>
+                </a:r>
+              </a:p>
+              <a:p>
+                <a:r>
+                  <a:rPr lang="en-AU" dirty="0"/>
+                  <a:t>│   ├── slam_auto_4.txt</a:t>
+                </a:r>
+              </a:p>
+              <a:p>
+                <a:r>
+                  <a:rPr lang="en-AU" dirty="0"/>
+                  <a:t>│   ├── slam_manual_1.txt</a:t>
+                </a:r>
+              </a:p>
+              <a:p>
+                <a:r>
+                  <a:rPr lang="en-AU" dirty="0"/>
+                  <a:t>│   ├── slam_manual_2.txt</a:t>
+                </a:r>
+              </a:p>
+              <a:p>
+                <a:r>
+                  <a:rPr lang="en-AU" dirty="0"/>
+                  <a:t>│   ├── targets_auto_4.txt</a:t>
+                </a:r>
+              </a:p>
+              <a:p>
+                <a:r>
+                  <a:rPr lang="en-AU" dirty="0"/>
+                  <a:t>│   ├── targets_manual_1.txt </a:t>
+                </a:r>
+              </a:p>
+              <a:p>
+                <a:r>
+                  <a:rPr lang="en-AU" dirty="0"/>
+                  <a:t>│   ├── targets_manual_2.txt </a:t>
+                </a:r>
+              </a:p>
+              <a:p>
+                <a:endParaRPr lang="en-GB" sz="1400" dirty="0"/>
+              </a:p>
+              <a:p>
+                <a:br>
+                  <a:rPr lang="en-GB" dirty="0"/>
+                </a:br>
+                <a:endParaRPr lang="en-GB" dirty="0"/>
+              </a:p>
+              <a:p>
+                <a:pPr algn="ctr"/>
+                <a:endParaRPr lang="en-GB" sz="1600" dirty="0">
+                  <a:solidFill>
+                    <a:schemeClr val="tx1"/>
+                  </a:solidFill>
+                </a:endParaRPr>
+              </a:p>
+              <a:p>
+                <a:pPr algn="ctr"/>
+                <a:endParaRPr lang="en-US" sz="1600" dirty="0">
+                  <a:solidFill>
+                    <a:schemeClr val="tx1"/>
+                  </a:solidFill>
+                </a:endParaRPr>
+              </a:p>
+              <a:p>
+                <a:endParaRPr lang="en-US" sz="1600" dirty="0"/>
+              </a:p>
+            </p:txBody>
+          </p:sp>
+        </mc:Choice>
+        <mc:Fallback xmlns="">
+          <p:sp>
+            <p:nvSpPr>
+              <p:cNvPr id="5" name="TextBox 4">
+                <a:extLst>
+                  <a:ext uri="{FF2B5EF4-FFF2-40B4-BE49-F238E27FC236}">
+                    <a16:creationId xmlns:a16="http://schemas.microsoft.com/office/drawing/2014/main" id="{777CEF6B-BB09-4C7B-EDC5-D0D9FC6E13C5}"/>
+                  </a:ext>
+                </a:extLst>
+              </p:cNvPr>
+              <p:cNvSpPr txBox="1">
+                <a:spLocks noRot="1" noChangeAspect="1" noMove="1" noResize="1" noEditPoints="1" noAdjustHandles="1" noChangeArrowheads="1" noChangeShapeType="1" noTextEdit="1"/>
+              </p:cNvSpPr>
+              <p:nvPr/>
+            </p:nvSpPr>
+            <p:spPr>
+              <a:xfrm>
+                <a:off x="478180" y="838376"/>
+                <a:ext cx="11588314" cy="7365093"/>
+              </a:xfrm>
+              <a:prstGeom prst="rect">
+                <a:avLst/>
+              </a:prstGeom>
+              <a:blipFill>
+                <a:blip r:embed="rId2"/>
+                <a:stretch>
+                  <a:fillRect l="-421"/>
+                </a:stretch>
+              </a:blipFill>
+            </p:spPr>
+            <p:txBody>
+              <a:bodyPr/>
+              <a:lstStyle/>
+              <a:p>
+                <a:r>
+                  <a:rPr lang="en-AU">
+                    <a:noFill/>
+                  </a:rPr>
+                  <a:t> </a:t>
+                </a:r>
+              </a:p>
+            </p:txBody>
+          </p:sp>
+        </mc:Fallback>
+      </mc:AlternateContent>
+    </p:spTree>
+    <p:extLst>
+      <p:ext uri="{BB962C8B-B14F-4D97-AF65-F5344CB8AC3E}">
+        <p14:creationId xmlns:p14="http://schemas.microsoft.com/office/powerpoint/2010/main" val="996172156"/>
+      </p:ext>
+    </p:extLst>
+  </p:cSld>
+  <p:clrMapOvr>
+    <a:masterClrMapping/>
+  </p:clrMapOvr>
+</p:sld>
+</file>
+
+<file path=ppt/slides/slide11.xml><?xml version="1.0" encoding="utf-8"?>
+<p:sld xmlns:a="http://schemas.openxmlformats.org/drawingml/2006/main" xmlns:r="http://schemas.openxmlformats.org/officeDocument/2006/relationships" xmlns:p="http://schemas.openxmlformats.org/presentationml/2006/main">
+  <p:cSld>
+    <p:spTree>
+      <p:nvGrpSpPr>
+        <p:cNvPr id="1" name="">
+          <a:extLst>
+            <a:ext uri="{FF2B5EF4-FFF2-40B4-BE49-F238E27FC236}">
+              <a16:creationId xmlns:a16="http://schemas.microsoft.com/office/drawing/2014/main" id="{E643B4D5-75D1-5E9D-D7AA-EC20CE52AB27}"/>
+            </a:ext>
+          </a:extLst>
+        </p:cNvPr>
+        <p:cNvGrpSpPr/>
+        <p:nvPr/>
+      </p:nvGrpSpPr>
+      <p:grpSpPr>
+        <a:xfrm>
+          <a:off x="0" y="0"/>
+          <a:ext cx="0" cy="0"/>
+          <a:chOff x="0" y="0"/>
+          <a:chExt cx="0" cy="0"/>
+        </a:xfrm>
+      </p:grpSpPr>
+      <p:sp>
+        <p:nvSpPr>
+          <p:cNvPr id="50" name="TextBox 49">
+            <a:extLst>
+              <a:ext uri="{FF2B5EF4-FFF2-40B4-BE49-F238E27FC236}">
+                <a16:creationId xmlns:a16="http://schemas.microsoft.com/office/drawing/2014/main" id="{AF9AD15C-3374-C999-432E-189131AF1255}"/>
+              </a:ext>
+            </a:extLst>
+          </p:cNvPr>
+          <p:cNvSpPr txBox="1"/>
+          <p:nvPr/>
+        </p:nvSpPr>
+        <p:spPr>
+          <a:xfrm>
+            <a:off x="478180" y="7379"/>
+            <a:ext cx="11713820" cy="830997"/>
+          </a:xfrm>
+          <a:prstGeom prst="rect">
+            <a:avLst/>
+          </a:prstGeom>
+          <a:noFill/>
+        </p:spPr>
+        <p:txBody>
+          <a:bodyPr wrap="square" rtlCol="0">
+            <a:spAutoFit/>
+          </a:bodyPr>
+          <a:lstStyle/>
+          <a:p>
+            <a:pPr algn="ctr"/>
+            <a:r>
+              <a:rPr lang="en-AU" sz="4800" dirty="0"/>
+              <a:t>Final Demo: Navigation</a:t>
+            </a:r>
+          </a:p>
+        </p:txBody>
+      </p:sp>
+      <p:sp>
+        <p:nvSpPr>
+          <p:cNvPr id="5" name="TextBox 4">
+            <a:extLst>
+              <a:ext uri="{FF2B5EF4-FFF2-40B4-BE49-F238E27FC236}">
+                <a16:creationId xmlns:a16="http://schemas.microsoft.com/office/drawing/2014/main" id="{E4632F9E-F91D-E5AD-EB97-9AF00468704C}"/>
+              </a:ext>
+            </a:extLst>
+          </p:cNvPr>
+          <p:cNvSpPr txBox="1"/>
+          <p:nvPr/>
+        </p:nvSpPr>
+        <p:spPr>
+          <a:xfrm>
+            <a:off x="478180" y="723232"/>
+            <a:ext cx="11588314" cy="5693866"/>
+          </a:xfrm>
+          <a:prstGeom prst="rect">
+            <a:avLst/>
+          </a:prstGeom>
+          <a:noFill/>
+        </p:spPr>
+        <p:txBody>
+          <a:bodyPr wrap="square" rtlCol="0">
+            <a:spAutoFit/>
+          </a:bodyPr>
+          <a:lstStyle/>
+          <a:p>
+            <a:r>
+              <a:rPr lang="en-US" sz="1600" dirty="0"/>
+              <a:t>Full auto navigation (max 70 points)</a:t>
+            </a:r>
+            <a:r>
+              <a:rPr lang="en-AU" sz="1600" dirty="0"/>
+              <a:t>:</a:t>
+            </a:r>
+            <a:endParaRPr lang="en-GB" dirty="0"/>
+          </a:p>
+          <a:p>
+            <a:pPr marL="285750" indent="-285750">
+              <a:buFont typeface="Arial" panose="020B0604020202020204" pitchFamily="34" charset="0"/>
+              <a:buChar char="•"/>
+            </a:pPr>
+            <a:r>
+              <a:rPr lang="en-GB" dirty="0"/>
+              <a:t>Level 1  </a:t>
+            </a:r>
+          </a:p>
+          <a:p>
+            <a:pPr marL="742950" lvl="1" indent="-285750">
+              <a:buFont typeface="Arial" panose="020B0604020202020204" pitchFamily="34" charset="0"/>
+              <a:buChar char="•"/>
+            </a:pPr>
+            <a:r>
+              <a:rPr lang="en-GB" dirty="0"/>
+              <a:t>15 marks awarded for a qualified run.  </a:t>
+            </a:r>
+          </a:p>
+          <a:p>
+            <a:pPr marL="742950" lvl="1" indent="-285750">
+              <a:buFont typeface="Arial" panose="020B0604020202020204" pitchFamily="34" charset="0"/>
+              <a:buChar char="•"/>
+            </a:pPr>
+            <a:r>
+              <a:rPr lang="en-GB" dirty="0"/>
+              <a:t>Each successful collection (within 0.3 m, in the correct shopping list order) is worth 5 marks.  </a:t>
+            </a:r>
+          </a:p>
+          <a:p>
+            <a:pPr marL="742950" lvl="1" indent="-285750">
+              <a:buFont typeface="Arial" panose="020B0604020202020204" pitchFamily="34" charset="0"/>
+              <a:buChar char="•"/>
+            </a:pPr>
+            <a:r>
+              <a:rPr lang="en-GB" dirty="0"/>
+              <a:t>Maximum contribution: 40% out of 70%.  </a:t>
+            </a:r>
+          </a:p>
+          <a:p>
+            <a:pPr marL="285750" indent="-285750">
+              <a:buFont typeface="Arial" panose="020B0604020202020204" pitchFamily="34" charset="0"/>
+              <a:buChar char="•"/>
+            </a:pPr>
+            <a:r>
+              <a:rPr lang="en-GB" dirty="0"/>
+              <a:t>Level 2  </a:t>
+            </a:r>
+          </a:p>
+          <a:p>
+            <a:pPr marL="742950" lvl="1" indent="-285750">
+              <a:buFont typeface="Arial" panose="020B0604020202020204" pitchFamily="34" charset="0"/>
+              <a:buChar char="•"/>
+            </a:pPr>
+            <a:r>
+              <a:rPr lang="en-GB" dirty="0"/>
+              <a:t>25 marks awarded for a qualified run.  </a:t>
+            </a:r>
+          </a:p>
+          <a:p>
+            <a:pPr marL="742950" lvl="1" indent="-285750">
+              <a:buFont typeface="Arial" panose="020B0604020202020204" pitchFamily="34" charset="0"/>
+              <a:buChar char="•"/>
+            </a:pPr>
+            <a:r>
+              <a:rPr lang="en-GB" dirty="0"/>
+              <a:t>Each successful collection (within 0.3 m, in the correct shopping list order) is worth 5 marks.  </a:t>
+            </a:r>
+          </a:p>
+          <a:p>
+            <a:pPr marL="742950" lvl="1" indent="-285750">
+              <a:buFont typeface="Arial" panose="020B0604020202020204" pitchFamily="34" charset="0"/>
+              <a:buChar char="•"/>
+            </a:pPr>
+            <a:r>
+              <a:rPr lang="en-GB" dirty="0"/>
+              <a:t>Maximum contribution: 50% out of 70%.  </a:t>
+            </a:r>
+          </a:p>
+          <a:p>
+            <a:pPr marL="285750" indent="-285750">
+              <a:buFont typeface="Arial" panose="020B0604020202020204" pitchFamily="34" charset="0"/>
+              <a:buChar char="•"/>
+            </a:pPr>
+            <a:r>
+              <a:rPr lang="en-GB" dirty="0"/>
+              <a:t>Level 3  </a:t>
+            </a:r>
+          </a:p>
+          <a:p>
+            <a:pPr marL="742950" lvl="1" indent="-285750">
+              <a:buFont typeface="Arial" panose="020B0604020202020204" pitchFamily="34" charset="0"/>
+              <a:buChar char="•"/>
+            </a:pPr>
+            <a:r>
+              <a:rPr lang="en-GB" dirty="0"/>
+              <a:t>30 marks awarded for a qualified run.  </a:t>
+            </a:r>
+          </a:p>
+          <a:p>
+            <a:pPr marL="742950" lvl="1" indent="-285750">
+              <a:buFont typeface="Arial" panose="020B0604020202020204" pitchFamily="34" charset="0"/>
+              <a:buChar char="•"/>
+            </a:pPr>
+            <a:r>
+              <a:rPr lang="en-GB" dirty="0"/>
+              <a:t>Each successful collection (within 0.3 m, in the correct shopping list order) is worth 8 marks.  </a:t>
+            </a:r>
+          </a:p>
+          <a:p>
+            <a:pPr marL="742950" lvl="1" indent="-285750">
+              <a:buFont typeface="Arial" panose="020B0604020202020204" pitchFamily="34" charset="0"/>
+              <a:buChar char="•"/>
+            </a:pPr>
+            <a:r>
+              <a:rPr lang="en-GB" dirty="0"/>
+              <a:t>Maximum contribution: 70% out of the 70% navigation mark (i.e. full 100%).  </a:t>
+            </a:r>
+            <a:endParaRPr lang="en-US" sz="1600" dirty="0"/>
+          </a:p>
+          <a:p>
+            <a:r>
+              <a:rPr lang="en-US" sz="1600" dirty="0"/>
+              <a:t>	</a:t>
+            </a:r>
+          </a:p>
+          <a:p>
+            <a:r>
+              <a:rPr lang="en-US" sz="1600" dirty="0"/>
+              <a:t>Penalties (Max of 5 penalties total,):</a:t>
+            </a:r>
+          </a:p>
+          <a:p>
+            <a:r>
+              <a:rPr lang="en-US" sz="1600" dirty="0"/>
+              <a:t>	-5 points for any collision</a:t>
+            </a:r>
+          </a:p>
+          <a:p>
+            <a:endParaRPr lang="en-US" sz="1600" dirty="0"/>
+          </a:p>
+          <a:p>
+            <a:r>
+              <a:rPr lang="en-US" sz="1600" dirty="0"/>
+              <a:t>Marks for reaching objects will always count, however you cannot stop a run manually until a run is qualified</a:t>
+            </a:r>
+          </a:p>
+          <a:p>
+            <a:endParaRPr lang="en-US" sz="1600" dirty="0"/>
+          </a:p>
+          <a:p>
+            <a:r>
+              <a:rPr lang="en-US" sz="1600" dirty="0"/>
+              <a:t>More info see Week11/README.md</a:t>
+            </a:r>
+            <a:endParaRPr lang="en-US" dirty="0">
+              <a:solidFill>
+                <a:schemeClr val="tx1"/>
+              </a:solidFill>
+            </a:endParaRPr>
+          </a:p>
+          <a:p>
+            <a:endParaRPr lang="en-US" sz="1600" dirty="0"/>
+          </a:p>
+        </p:txBody>
+      </p:sp>
+    </p:spTree>
+    <p:extLst>
+      <p:ext uri="{BB962C8B-B14F-4D97-AF65-F5344CB8AC3E}">
+        <p14:creationId xmlns:p14="http://schemas.microsoft.com/office/powerpoint/2010/main" val="2200729387"/>
+      </p:ext>
+    </p:extLst>
+  </p:cSld>
+  <p:clrMapOvr>
+    <a:masterClrMapping/>
+  </p:clrMapOvr>
+</p:sld>
+</file>
+
 <file path=ppt/slides/slide2.xml><?xml version="1.0" encoding="utf-8"?>
 <p:sld xmlns:a="http://schemas.openxmlformats.org/drawingml/2006/main" xmlns:r="http://schemas.openxmlformats.org/officeDocument/2006/relationships" xmlns:p="http://schemas.openxmlformats.org/presentationml/2006/main">
   <p:cSld>
@@ -6806,10 +7689,6 @@
             </a:r>
           </a:p>
           <a:p>
-            <a:pPr marL="342900" indent="-342900">
-              <a:buFont typeface="Arial" panose="020B0604020202020204" pitchFamily="34" charset="0"/>
-              <a:buChar char="•"/>
-            </a:pPr>
             <a:r>
               <a:rPr lang="en-US" dirty="0"/>
               <a:t>The arena will always contain:</a:t>
@@ -7143,7 +8022,7 @@
             </a:pPr>
             <a:r>
               <a:rPr lang="en-GB" dirty="0"/>
-              <a:t>You must navigate to targets on the shopping list in the specified order</a:t>
+              <a:t>You must navigate to targets on the shopping list as specified by level 3 requirements</a:t>
             </a:r>
           </a:p>
           <a:p>
@@ -7662,7 +8541,7 @@
             <a:pPr algn="ctr"/>
             <a:r>
               <a:rPr lang="en-AU" sz="4800" dirty="0"/>
-              <a:t>Additional recommendations (optional)</a:t>
+              <a:t>Additional recommendations</a:t>
             </a:r>
           </a:p>
         </p:txBody>
@@ -7682,7 +8561,7 @@
         <p:spPr>
           <a:xfrm>
             <a:off x="666931" y="1104222"/>
-            <a:ext cx="11387610" cy="4247317"/>
+            <a:ext cx="11336318" cy="4524315"/>
           </a:xfrm>
           <a:prstGeom prst="rect">
             <a:avLst/>
@@ -7696,50 +8575,73 @@
           <a:lstStyle/>
           <a:p>
             <a:r>
+              <a:rPr lang="en-AU" dirty="0">
+                <a:solidFill>
+                  <a:srgbClr val="FFC000"/>
+                </a:solidFill>
+              </a:rPr>
+              <a:t>- Add a stop button</a:t>
+            </a:r>
+          </a:p>
+          <a:p>
+            <a:r>
               <a:rPr lang="en-AU" dirty="0"/>
-              <a:t>- Waypoint thresholding</a:t>
+              <a:t>	</a:t>
             </a:r>
           </a:p>
           <a:p>
             <a:r>
               <a:rPr lang="en-AU" dirty="0"/>
-              <a:t>	You can set an appropriate threshold so the robot doesn’t have to get too close to a waypoint point 	and get fixated at trying to do so</a:t>
-            </a:r>
-          </a:p>
-          <a:p>
-            <a:br>
+              <a:t>	Adding a stop button that makes the robot wheels stop without shutting the robot down or stopping 	your operate script would save some time and effort when you want to quickly start a new run.</a:t>
+            </a:r>
+          </a:p>
+          <a:p>
+            <a:endParaRPr lang="en-AU" dirty="0">
+              <a:solidFill>
+                <a:srgbClr val="FFC000"/>
+              </a:solidFill>
+            </a:endParaRPr>
+          </a:p>
+          <a:p>
+            <a:r>
+              <a:rPr lang="en-AU" dirty="0">
+                <a:solidFill>
+                  <a:srgbClr val="FFC000"/>
+                </a:solidFill>
+              </a:rPr>
+              <a:t>- Optimise turning and reverse driving</a:t>
+            </a:r>
+          </a:p>
+          <a:p>
+            <a:endParaRPr lang="en-AU" dirty="0"/>
+          </a:p>
+          <a:p>
+            <a:r>
               <a:rPr lang="en-AU" dirty="0"/>
-            </a:br>
+              <a:t>	Turning is the reason to many collisions when your robot gets too close to a marker or a target. 	Optimising robot movements by turning the shorter (as opposed to fixed left turning, for example) 	and allow reverse driving would prevent this. This also reduce the driving time.</a:t>
+            </a:r>
+          </a:p>
+          <a:p>
+            <a:endParaRPr lang="en-AU" dirty="0"/>
+          </a:p>
+          <a:p>
+            <a:r>
+              <a:rPr lang="en-AU" dirty="0">
+                <a:solidFill>
+                  <a:srgbClr val="FFC000"/>
+                </a:solidFill>
+              </a:rPr>
+              <a:t>- Clean up your submission</a:t>
+            </a:r>
+          </a:p>
+          <a:p>
+            <a:endParaRPr lang="en-AU" dirty="0"/>
+          </a:p>
+          <a:p>
             <a:r>
               <a:rPr lang="en-AU" dirty="0"/>
-              <a:t>	If this fixation is due to the robot thinking it “teleported” due to an update of its position from seeing 	an </a:t>
-            </a:r>
-            <a:r>
-              <a:rPr lang="en-AU" dirty="0" err="1"/>
-              <a:t>ArUco</a:t>
-            </a:r>
-            <a:r>
-              <a:rPr lang="en-AU" dirty="0"/>
-              <a:t> marker, then you may need to decrease the uncertainty in the predict step so it relies on 	the robot’s dynamics a bit more </a:t>
-            </a:r>
-          </a:p>
-          <a:p>
-            <a:endParaRPr lang="en-AU" dirty="0"/>
-          </a:p>
-          <a:p>
-            <a:endParaRPr lang="en-AU" dirty="0"/>
-          </a:p>
-          <a:p>
-            <a:endParaRPr lang="en-AU" dirty="0"/>
-          </a:p>
-          <a:p>
-            <a:r>
-              <a:rPr lang="en-AU" dirty="0"/>
-              <a:t>Remember, the skeleton codes are for reference only and you’ll have to improve the codes or write your own to get better marks. As long as your codes perform the task and generate estimation maps that can be marked according to the evaluation schemes and scripts you are free to modify the skeleton codes.</a:t>
-            </a:r>
-          </a:p>
-          <a:p>
-            <a:endParaRPr lang="en-AU" dirty="0"/>
+              <a:t>	A clean submission prevent the risk of using the wrong files for your final demo, so make sure it only 	contains the files you need.</a:t>
+            </a:r>
           </a:p>
           <a:p>
             <a:endParaRPr lang="en-AU" dirty="0"/>
@@ -7749,7 +8651,7 @@
     </p:spTree>
     <p:extLst>
       <p:ext uri="{BB962C8B-B14F-4D97-AF65-F5344CB8AC3E}">
-        <p14:creationId xmlns:p14="http://schemas.microsoft.com/office/powerpoint/2010/main" val="2468866585"/>
+        <p14:creationId xmlns:p14="http://schemas.microsoft.com/office/powerpoint/2010/main" val="4221252979"/>
       </p:ext>
     </p:extLst>
   </p:cSld>
@@ -7790,7 +8692,7 @@
         </p:nvSpPr>
         <p:spPr>
           <a:xfrm>
-            <a:off x="478180" y="7379"/>
+            <a:off x="478180" y="172557"/>
             <a:ext cx="11713820" cy="830997"/>
           </a:xfrm>
           <a:prstGeom prst="rect">
@@ -7807,17 +8709,17 @@
             <a:pPr algn="ctr"/>
             <a:r>
               <a:rPr lang="en-AU" sz="4800" dirty="0"/>
-              <a:t>Final Demo: Evaluation</a:t>
+              <a:t>Additional recommendations</a:t>
             </a:r>
           </a:p>
         </p:txBody>
       </p:sp>
       <p:sp>
         <p:nvSpPr>
-          <p:cNvPr id="4" name="TextBox 3">
+          <p:cNvPr id="51" name="TextBox 50">
             <a:extLst>
               <a:ext uri="{FF2B5EF4-FFF2-40B4-BE49-F238E27FC236}">
-                <a16:creationId xmlns:a16="http://schemas.microsoft.com/office/drawing/2014/main" id="{CA0B27D3-7B85-4485-A10E-AAC012A9B3BB}"/>
+                <a16:creationId xmlns:a16="http://schemas.microsoft.com/office/drawing/2014/main" id="{23C81F35-1469-4804-9BCB-5A04321DD9C5}"/>
               </a:ext>
             </a:extLst>
           </p:cNvPr>
@@ -7826,8 +8728,8 @@
         </p:nvSpPr>
         <p:spPr>
           <a:xfrm>
-            <a:off x="478180" y="723232"/>
-            <a:ext cx="11588314" cy="646331"/>
+            <a:off x="666931" y="1003554"/>
+            <a:ext cx="11336318" cy="4524315"/>
           </a:xfrm>
           <a:prstGeom prst="rect">
             <a:avLst/>
@@ -7840,19 +8742,303 @@
           </a:bodyPr>
           <a:lstStyle/>
           <a:p>
-            <a:pPr algn="ctr"/>
-            <a:r>
-              <a:rPr lang="en-AU" sz="3600" dirty="0"/>
-              <a:t>To be added later</a:t>
-            </a:r>
-            <a:endParaRPr lang="en-US" sz="3600" dirty="0"/>
+            <a:r>
+              <a:rPr lang="en-AU" dirty="0">
+                <a:solidFill>
+                  <a:srgbClr val="FFC000"/>
+                </a:solidFill>
+              </a:rPr>
+              <a:t>- Optimise sample-based path planner</a:t>
+            </a:r>
+          </a:p>
+          <a:p>
+            <a:endParaRPr lang="en-AU" dirty="0"/>
+          </a:p>
+          <a:p>
+            <a:r>
+              <a:rPr lang="en-AU" dirty="0"/>
+              <a:t>	Sample-based path planners like RRT does not produce the optimal path most of the time, but they 	run very fast. To further optimise this, you can generate multiple potential paths and select the best 	one based on certain criteria. For example:</a:t>
+            </a:r>
+          </a:p>
+          <a:p>
+            <a:r>
+              <a:rPr lang="en-AU" dirty="0"/>
+              <a:t>		- Number of waypoints</a:t>
+            </a:r>
+          </a:p>
+          <a:p>
+            <a:r>
+              <a:rPr lang="en-AU" dirty="0"/>
+              <a:t>		- Total distance travelled</a:t>
+            </a:r>
+          </a:p>
+          <a:p>
+            <a:r>
+              <a:rPr lang="en-AU" dirty="0"/>
+              <a:t>		- Average distance between the waypoints and the obstacles</a:t>
+            </a:r>
+            <a:endParaRPr lang="en-AU" dirty="0">
+              <a:solidFill>
+                <a:srgbClr val="FFC000"/>
+              </a:solidFill>
+            </a:endParaRPr>
+          </a:p>
+          <a:p>
+            <a:endParaRPr lang="en-AU" dirty="0">
+              <a:solidFill>
+                <a:srgbClr val="FFC000"/>
+              </a:solidFill>
+            </a:endParaRPr>
+          </a:p>
+          <a:p>
+            <a:r>
+              <a:rPr lang="en-AU" dirty="0">
+                <a:solidFill>
+                  <a:srgbClr val="FFC000"/>
+                </a:solidFill>
+              </a:rPr>
+              <a:t>- Collision detection</a:t>
+            </a:r>
+          </a:p>
+          <a:p>
+            <a:r>
+              <a:rPr lang="en-AU" dirty="0"/>
+              <a:t>	</a:t>
+            </a:r>
+          </a:p>
+          <a:p>
+            <a:r>
+              <a:rPr lang="en-AU" dirty="0"/>
+              <a:t>	Your robot can use its camera to work out the distance towards a marker (using aruco_detector.py) 	for a </a:t>
+            </a:r>
+            <a:r>
+              <a:rPr lang="en-AU" dirty="0" err="1"/>
+              <a:t>fruit&amp;veg</a:t>
+            </a:r>
+            <a:r>
+              <a:rPr lang="en-AU" dirty="0"/>
+              <a:t> (using detector.py). If the distance is too close, you will want to stop a robot and find 	a detour / back off.</a:t>
+            </a:r>
+          </a:p>
+          <a:p>
+            <a:endParaRPr lang="en-AU" dirty="0">
+              <a:solidFill>
+                <a:srgbClr val="FFC000"/>
+              </a:solidFill>
+            </a:endParaRPr>
+          </a:p>
+          <a:p>
+            <a:endParaRPr lang="en-AU" dirty="0"/>
           </a:p>
         </p:txBody>
       </p:sp>
     </p:spTree>
     <p:extLst>
       <p:ext uri="{BB962C8B-B14F-4D97-AF65-F5344CB8AC3E}">
-        <p14:creationId xmlns:p14="http://schemas.microsoft.com/office/powerpoint/2010/main" val="996172156"/>
+        <p14:creationId xmlns:p14="http://schemas.microsoft.com/office/powerpoint/2010/main" val="2773337027"/>
+      </p:ext>
+    </p:extLst>
+  </p:cSld>
+  <p:clrMapOvr>
+    <a:masterClrMapping/>
+  </p:clrMapOvr>
+</p:sld>
+</file>
+
+<file path=ppt/slides/slide9.xml><?xml version="1.0" encoding="utf-8"?>
+<p:sld xmlns:a="http://schemas.openxmlformats.org/drawingml/2006/main" xmlns:r="http://schemas.openxmlformats.org/officeDocument/2006/relationships" xmlns:p="http://schemas.openxmlformats.org/presentationml/2006/main">
+  <p:cSld>
+    <p:spTree>
+      <p:nvGrpSpPr>
+        <p:cNvPr id="1" name=""/>
+        <p:cNvGrpSpPr/>
+        <p:nvPr/>
+      </p:nvGrpSpPr>
+      <p:grpSpPr>
+        <a:xfrm>
+          <a:off x="0" y="0"/>
+          <a:ext cx="0" cy="0"/>
+          <a:chOff x="0" y="0"/>
+          <a:chExt cx="0" cy="0"/>
+        </a:xfrm>
+      </p:grpSpPr>
+      <p:sp>
+        <p:nvSpPr>
+          <p:cNvPr id="50" name="TextBox 49">
+            <a:extLst>
+              <a:ext uri="{FF2B5EF4-FFF2-40B4-BE49-F238E27FC236}">
+                <a16:creationId xmlns:a16="http://schemas.microsoft.com/office/drawing/2014/main" id="{BF948A99-782B-4139-A61F-6C2663DAEB76}"/>
+              </a:ext>
+            </a:extLst>
+          </p:cNvPr>
+          <p:cNvSpPr txBox="1"/>
+          <p:nvPr/>
+        </p:nvSpPr>
+        <p:spPr>
+          <a:xfrm>
+            <a:off x="478180" y="172557"/>
+            <a:ext cx="11713820" cy="830997"/>
+          </a:xfrm>
+          <a:prstGeom prst="rect">
+            <a:avLst/>
+          </a:prstGeom>
+          <a:noFill/>
+        </p:spPr>
+        <p:txBody>
+          <a:bodyPr wrap="square" rtlCol="0">
+            <a:spAutoFit/>
+          </a:bodyPr>
+          <a:lstStyle/>
+          <a:p>
+            <a:pPr algn="ctr"/>
+            <a:r>
+              <a:rPr lang="en-AU" sz="4800" dirty="0"/>
+              <a:t>Additional recommendations</a:t>
+            </a:r>
+          </a:p>
+        </p:txBody>
+      </p:sp>
+      <p:sp>
+        <p:nvSpPr>
+          <p:cNvPr id="51" name="TextBox 50">
+            <a:extLst>
+              <a:ext uri="{FF2B5EF4-FFF2-40B4-BE49-F238E27FC236}">
+                <a16:creationId xmlns:a16="http://schemas.microsoft.com/office/drawing/2014/main" id="{23C81F35-1469-4804-9BCB-5A04321DD9C5}"/>
+              </a:ext>
+            </a:extLst>
+          </p:cNvPr>
+          <p:cNvSpPr txBox="1"/>
+          <p:nvPr/>
+        </p:nvSpPr>
+        <p:spPr>
+          <a:xfrm>
+            <a:off x="666931" y="1003554"/>
+            <a:ext cx="11336318" cy="5632311"/>
+          </a:xfrm>
+          <a:prstGeom prst="rect">
+            <a:avLst/>
+          </a:prstGeom>
+          <a:noFill/>
+        </p:spPr>
+        <p:txBody>
+          <a:bodyPr wrap="square" rtlCol="0">
+            <a:spAutoFit/>
+          </a:bodyPr>
+          <a:lstStyle/>
+          <a:p>
+            <a:r>
+              <a:rPr lang="en-AU" dirty="0">
+                <a:solidFill>
+                  <a:srgbClr val="FFC000"/>
+                </a:solidFill>
+              </a:rPr>
+              <a:t>- Everything is variable</a:t>
+            </a:r>
+          </a:p>
+          <a:p>
+            <a:endParaRPr lang="en-AU" dirty="0">
+              <a:solidFill>
+                <a:srgbClr val="FFC000"/>
+              </a:solidFill>
+            </a:endParaRPr>
+          </a:p>
+          <a:p>
+            <a:r>
+              <a:rPr lang="en-AU" dirty="0"/>
+              <a:t>	As changing the submitted code is not allowed, it’s best not to hardcode your important variables and 	make them dynamic arguments than can be changed by the command line. Some important 	variables:</a:t>
+            </a:r>
+          </a:p>
+          <a:p>
+            <a:r>
+              <a:rPr lang="en-AU" dirty="0"/>
+              <a:t>		- Obstacle radius</a:t>
+            </a:r>
+          </a:p>
+          <a:p>
+            <a:r>
+              <a:rPr lang="en-AU" dirty="0"/>
+              <a:t>		- Distance to the target (to consider collection)</a:t>
+            </a:r>
+          </a:p>
+          <a:p>
+            <a:r>
+              <a:rPr lang="en-AU" dirty="0"/>
+              <a:t>		- Input files name</a:t>
+            </a:r>
+          </a:p>
+          <a:p>
+            <a:r>
+              <a:rPr lang="en-AU" dirty="0"/>
+              <a:t>		- etc.</a:t>
+            </a:r>
+          </a:p>
+          <a:p>
+            <a:r>
+              <a:rPr lang="en-AU" dirty="0"/>
+              <a:t>	Alternative, some of these can even dynamically change while the script is running. For example, if 	your path planner is stuck, you might want to reduce the obstacle radius automatically.</a:t>
+            </a:r>
+          </a:p>
+          <a:p>
+            <a:endParaRPr lang="en-AU" dirty="0">
+              <a:solidFill>
+                <a:srgbClr val="FFC000"/>
+              </a:solidFill>
+            </a:endParaRPr>
+          </a:p>
+          <a:p>
+            <a:r>
+              <a:rPr lang="en-AU" dirty="0">
+                <a:solidFill>
+                  <a:srgbClr val="FFC000"/>
+                </a:solidFill>
+              </a:rPr>
+              <a:t>- Get out of obstacles</a:t>
+            </a:r>
+          </a:p>
+          <a:p>
+            <a:endParaRPr lang="en-AU" dirty="0">
+              <a:solidFill>
+                <a:srgbClr val="FFC000"/>
+              </a:solidFill>
+            </a:endParaRPr>
+          </a:p>
+          <a:p>
+            <a:pPr lvl="1"/>
+            <a:r>
+              <a:rPr lang="en-AU" dirty="0"/>
+              <a:t>Sometimes you will find your robot stuck inside an obstacle and all the proposed paths are failed due to collision. Follows are some suggestions:</a:t>
+            </a:r>
+          </a:p>
+          <a:p>
+            <a:pPr lvl="1"/>
+            <a:r>
+              <a:rPr lang="en-AU" dirty="0"/>
+              <a:t>	- Reduce the obstacle radius automatically</a:t>
+            </a:r>
+          </a:p>
+          <a:p>
+            <a:pPr lvl="1"/>
+            <a:r>
+              <a:rPr lang="en-AU" dirty="0"/>
+              <a:t>	- Trace back to your previous waypoints or origin</a:t>
+            </a:r>
+          </a:p>
+          <a:p>
+            <a:pPr lvl="1"/>
+            <a:r>
+              <a:rPr lang="en-AU" dirty="0"/>
+              <a:t>	- Go to a random non-occupied point   </a:t>
+            </a:r>
+          </a:p>
+          <a:p>
+            <a:endParaRPr lang="en-AU" dirty="0"/>
+          </a:p>
+        </p:txBody>
+      </p:sp>
+    </p:spTree>
+    <p:extLst>
+      <p:ext uri="{BB962C8B-B14F-4D97-AF65-F5344CB8AC3E}">
+        <p14:creationId xmlns:p14="http://schemas.microsoft.com/office/powerpoint/2010/main" val="3747830525"/>
       </p:ext>
     </p:extLst>
   </p:cSld>

</xml_diff>

<commit_message>
Updating marking formula for SLAM in slides
</commit_message>
<xml_diff>
--- a/Week09-10/C2_slides/Lab5_2.pptx
+++ b/Week09-10/C2_slides/Lab5_2.pptx
@@ -251,7 +251,7 @@
           <a:p>
             <a:fld id="{A9407A57-47BC-45C1-B9EB-906F4463B0AB}" type="datetimeFigureOut">
               <a:rPr lang="en-AU" smtClean="0"/>
-              <a:t>7/10/2025</a:t>
+              <a:t>8/10/2025</a:t>
             </a:fld>
             <a:endParaRPr lang="en-AU"/>
           </a:p>
@@ -687,7 +687,7 @@
           <a:p>
             <a:fld id="{1205BC88-DBF0-4610-A802-A09E0A6ECD22}" type="datetimeFigureOut">
               <a:rPr lang="en-AU" smtClean="0"/>
-              <a:t>7/10/2025</a:t>
+              <a:t>8/10/2025</a:t>
             </a:fld>
             <a:endParaRPr lang="en-AU"/>
           </a:p>
@@ -922,7 +922,7 @@
           <a:p>
             <a:fld id="{1205BC88-DBF0-4610-A802-A09E0A6ECD22}" type="datetimeFigureOut">
               <a:rPr lang="en-AU" smtClean="0"/>
-              <a:t>7/10/2025</a:t>
+              <a:t>8/10/2025</a:t>
             </a:fld>
             <a:endParaRPr lang="en-AU"/>
           </a:p>
@@ -1102,7 +1102,7 @@
           <a:p>
             <a:fld id="{1205BC88-DBF0-4610-A802-A09E0A6ECD22}" type="datetimeFigureOut">
               <a:rPr lang="en-AU" smtClean="0"/>
-              <a:t>7/10/2025</a:t>
+              <a:t>8/10/2025</a:t>
             </a:fld>
             <a:endParaRPr lang="en-AU"/>
           </a:p>
@@ -1272,7 +1272,7 @@
           <a:p>
             <a:fld id="{1205BC88-DBF0-4610-A802-A09E0A6ECD22}" type="datetimeFigureOut">
               <a:rPr lang="en-AU" smtClean="0"/>
-              <a:t>7/10/2025</a:t>
+              <a:t>8/10/2025</a:t>
             </a:fld>
             <a:endParaRPr lang="en-AU"/>
           </a:p>
@@ -1526,7 +1526,7 @@
           <a:p>
             <a:fld id="{1205BC88-DBF0-4610-A802-A09E0A6ECD22}" type="datetimeFigureOut">
               <a:rPr lang="en-AU" smtClean="0"/>
-              <a:t>7/10/2025</a:t>
+              <a:t>8/10/2025</a:t>
             </a:fld>
             <a:endParaRPr lang="en-AU"/>
           </a:p>
@@ -1852,7 +1852,7 @@
           <a:p>
             <a:fld id="{1205BC88-DBF0-4610-A802-A09E0A6ECD22}" type="datetimeFigureOut">
               <a:rPr lang="en-AU" smtClean="0"/>
-              <a:t>7/10/2025</a:t>
+              <a:t>8/10/2025</a:t>
             </a:fld>
             <a:endParaRPr lang="en-AU"/>
           </a:p>
@@ -2303,7 +2303,7 @@
           <a:p>
             <a:fld id="{1205BC88-DBF0-4610-A802-A09E0A6ECD22}" type="datetimeFigureOut">
               <a:rPr lang="en-AU" smtClean="0"/>
-              <a:t>7/10/2025</a:t>
+              <a:t>8/10/2025</a:t>
             </a:fld>
             <a:endParaRPr lang="en-AU"/>
           </a:p>
@@ -2421,7 +2421,7 @@
           <a:p>
             <a:fld id="{1205BC88-DBF0-4610-A802-A09E0A6ECD22}" type="datetimeFigureOut">
               <a:rPr lang="en-AU" smtClean="0"/>
-              <a:t>7/10/2025</a:t>
+              <a:t>8/10/2025</a:t>
             </a:fld>
             <a:endParaRPr lang="en-AU"/>
           </a:p>
@@ -2516,7 +2516,7 @@
           <a:p>
             <a:fld id="{1205BC88-DBF0-4610-A802-A09E0A6ECD22}" type="datetimeFigureOut">
               <a:rPr lang="en-AU" smtClean="0"/>
-              <a:t>7/10/2025</a:t>
+              <a:t>8/10/2025</a:t>
             </a:fld>
             <a:endParaRPr lang="en-AU"/>
           </a:p>
@@ -2803,7 +2803,7 @@
           <a:p>
             <a:fld id="{1205BC88-DBF0-4610-A802-A09E0A6ECD22}" type="datetimeFigureOut">
               <a:rPr lang="en-AU" smtClean="0"/>
-              <a:t>7/10/2025</a:t>
+              <a:t>8/10/2025</a:t>
             </a:fld>
             <a:endParaRPr lang="en-AU"/>
           </a:p>
@@ -3125,7 +3125,7 @@
           <a:p>
             <a:fld id="{1205BC88-DBF0-4610-A802-A09E0A6ECD22}" type="datetimeFigureOut">
               <a:rPr lang="en-AU" smtClean="0"/>
-              <a:t>7/10/2025</a:t>
+              <a:t>8/10/2025</a:t>
             </a:fld>
             <a:endParaRPr lang="en-AU"/>
           </a:p>
@@ -3386,7 +3386,7 @@
           <a:p>
             <a:fld id="{1205BC88-DBF0-4610-A802-A09E0A6ECD22}" type="datetimeFigureOut">
               <a:rPr lang="en-AU" smtClean="0"/>
-              <a:t>7/10/2025</a:t>
+              <a:t>8/10/2025</a:t>
             </a:fld>
             <a:endParaRPr lang="en-AU"/>
           </a:p>
@@ -4160,8 +4160,8 @@
           </a:p>
         </p:txBody>
       </p:sp>
-      <mc:AlternateContent xmlns:mc="http://schemas.openxmlformats.org/markup-compatibility/2006" xmlns:a14="http://schemas.microsoft.com/office/drawing/2010/main">
-        <mc:Choice Requires="a14">
+      <mc:AlternateContent xmlns:mc="http://schemas.openxmlformats.org/markup-compatibility/2006">
+        <mc:Choice xmlns:a14="http://schemas.microsoft.com/office/drawing/2010/main" Requires="a14">
           <p:sp>
             <p:nvSpPr>
               <p:cNvPr id="5" name="TextBox 4">
@@ -4177,7 +4177,7 @@
             <p:spPr>
               <a:xfrm>
                 <a:off x="478180" y="838376"/>
-                <a:ext cx="11588314" cy="7365093"/>
+                <a:ext cx="11588314" cy="5580630"/>
               </a:xfrm>
               <a:prstGeom prst="rect">
                 <a:avLst/>
@@ -4197,6 +4197,228 @@
                   <a:rPr lang="en-US" sz="1600" dirty="0"/>
                   <a:t>Mapping (30 points):</a:t>
                 </a:r>
+              </a:p>
+              <a:p>
+                <a:pPr algn="ctr"/>
+                <a:r>
+                  <a:rPr lang="en-GB" sz="1600" dirty="0" err="1"/>
+                  <a:t>slam_rating</a:t>
+                </a:r>
+                <a:r>
+                  <a:rPr lang="en-GB" sz="1600" dirty="0"/>
+                  <a:t>= </a:t>
+                </a:r>
+                <a14:m>
+                  <m:oMath xmlns:m="http://schemas.openxmlformats.org/officeDocument/2006/math">
+                    <m:f>
+                      <m:fPr>
+                        <m:ctrlPr>
+                          <a:rPr lang="en-GB" sz="1600" i="1" dirty="0">
+                            <a:latin typeface="Cambria Math" panose="02040503050406030204" pitchFamily="18" charset="0"/>
+                          </a:rPr>
+                        </m:ctrlPr>
+                      </m:fPr>
+                      <m:num>
+                        <m:r>
+                          <a:rPr lang="en-GB" sz="1600" i="1" dirty="0">
+                            <a:latin typeface="Cambria Math" panose="02040503050406030204" pitchFamily="18" charset="0"/>
+                          </a:rPr>
+                          <m:t>0.</m:t>
+                        </m:r>
+                        <m:r>
+                          <a:rPr lang="en-AU" sz="1600" i="1" dirty="0">
+                            <a:latin typeface="Cambria Math" panose="02040503050406030204" pitchFamily="18" charset="0"/>
+                          </a:rPr>
+                          <m:t>2</m:t>
+                        </m:r>
+                        <m:r>
+                          <a:rPr lang="en-GB" sz="1600" i="1" dirty="0">
+                            <a:latin typeface="Cambria Math" panose="02040503050406030204" pitchFamily="18" charset="0"/>
+                          </a:rPr>
+                          <m:t> −</m:t>
+                        </m:r>
+                        <m:r>
+                          <a:rPr lang="en-AU" sz="1600" i="1" dirty="0">
+                            <a:latin typeface="Cambria Math" panose="02040503050406030204" pitchFamily="18" charset="0"/>
+                          </a:rPr>
+                          <m:t>𝑠𝑙𝑎𝑚</m:t>
+                        </m:r>
+                        <m:r>
+                          <a:rPr lang="en-AU" sz="1600" i="1" dirty="0">
+                            <a:latin typeface="Cambria Math" panose="02040503050406030204" pitchFamily="18" charset="0"/>
+                          </a:rPr>
+                          <m:t>_</m:t>
+                        </m:r>
+                        <m:r>
+                          <a:rPr lang="en-AU" sz="1600" i="1" dirty="0">
+                            <a:latin typeface="Cambria Math" panose="02040503050406030204" pitchFamily="18" charset="0"/>
+                          </a:rPr>
+                          <m:t>𝑟𝑚𝑠𝑒</m:t>
+                        </m:r>
+                      </m:num>
+                      <m:den>
+                        <m:r>
+                          <a:rPr lang="en-GB" sz="1600" i="1" dirty="0">
+                            <a:latin typeface="Cambria Math" panose="02040503050406030204" pitchFamily="18" charset="0"/>
+                          </a:rPr>
+                          <m:t>0.</m:t>
+                        </m:r>
+                        <m:r>
+                          <a:rPr lang="en-AU" sz="1600" i="1" dirty="0">
+                            <a:latin typeface="Cambria Math" panose="02040503050406030204" pitchFamily="18" charset="0"/>
+                          </a:rPr>
+                          <m:t>2</m:t>
+                        </m:r>
+                        <m:r>
+                          <a:rPr lang="en-GB" sz="1600" i="1" dirty="0">
+                            <a:latin typeface="Cambria Math" panose="02040503050406030204" pitchFamily="18" charset="0"/>
+                          </a:rPr>
+                          <m:t>−0.02</m:t>
+                        </m:r>
+                      </m:den>
+                    </m:f>
+                    <m:r>
+                      <a:rPr lang="en-GB" sz="1600" i="1" dirty="0">
+                        <a:latin typeface="Cambria Math" panose="02040503050406030204" pitchFamily="18" charset="0"/>
+                      </a:rPr>
+                      <m:t> </m:t>
+                    </m:r>
+                  </m:oMath>
+                </a14:m>
+                <a:endParaRPr lang="en-GB" sz="1600" dirty="0">
+                  <a:solidFill>
+                    <a:srgbClr val="FFFF00"/>
+                  </a:solidFill>
+                </a:endParaRPr>
+              </a:p>
+              <a:p>
+                <a:pPr algn="ctr"/>
+                <a:r>
+                  <a:rPr lang="en-GB" sz="1600" dirty="0"/>
+                  <a:t>slam _score = </a:t>
+                </a:r>
+                <a14:m>
+                  <m:oMath xmlns:m="http://schemas.openxmlformats.org/officeDocument/2006/math">
+                    <m:f>
+                      <m:fPr>
+                        <m:ctrlPr>
+                          <a:rPr lang="en-GB" sz="1600" i="1" dirty="0">
+                            <a:latin typeface="Cambria Math" panose="02040503050406030204" pitchFamily="18" charset="0"/>
+                          </a:rPr>
+                        </m:ctrlPr>
+                      </m:fPr>
+                      <m:num>
+                        <m:r>
+                          <a:rPr lang="en-GB" sz="1600" i="1" dirty="0" err="1">
+                            <a:latin typeface="Cambria Math" panose="02040503050406030204" pitchFamily="18" charset="0"/>
+                          </a:rPr>
+                          <m:t>𝑏𝑎𝑠</m:t>
+                        </m:r>
+                        <m:sSup>
+                          <m:sSupPr>
+                            <m:ctrlPr>
+                              <a:rPr lang="en-GB" sz="1600" i="1" dirty="0" err="1">
+                                <a:latin typeface="Cambria Math" panose="02040503050406030204" pitchFamily="18" charset="0"/>
+                              </a:rPr>
+                            </m:ctrlPr>
+                          </m:sSupPr>
+                          <m:e>
+                            <m:r>
+                              <a:rPr lang="en-GB" sz="1600" i="1" dirty="0" err="1">
+                                <a:latin typeface="Cambria Math" panose="02040503050406030204" pitchFamily="18" charset="0"/>
+                              </a:rPr>
+                              <m:t>𝑒</m:t>
+                            </m:r>
+                          </m:e>
+                          <m:sup>
+                            <m:r>
+                              <a:rPr lang="en-AU" sz="1600" i="1" dirty="0">
+                                <a:latin typeface="Cambria Math" panose="02040503050406030204" pitchFamily="18" charset="0"/>
+                              </a:rPr>
+                              <m:t>𝑠𝑙𝑎𝑚</m:t>
+                            </m:r>
+                            <m:r>
+                              <a:rPr lang="en-AU" sz="1600" i="1" dirty="0">
+                                <a:latin typeface="Cambria Math" panose="02040503050406030204" pitchFamily="18" charset="0"/>
+                              </a:rPr>
+                              <m:t>_</m:t>
+                            </m:r>
+                            <m:r>
+                              <a:rPr lang="en-AU" sz="1600" i="1" dirty="0">
+                                <a:latin typeface="Cambria Math" panose="02040503050406030204" pitchFamily="18" charset="0"/>
+                              </a:rPr>
+                              <m:t>𝑟𝑎𝑡𝑖𝑛𝑔</m:t>
+                            </m:r>
+                          </m:sup>
+                        </m:sSup>
+                        <m:r>
+                          <a:rPr lang="en-GB" sz="1600" i="1" dirty="0">
+                            <a:latin typeface="Cambria Math" panose="02040503050406030204" pitchFamily="18" charset="0"/>
+                          </a:rPr>
+                          <m:t>– 1</m:t>
+                        </m:r>
+                      </m:num>
+                      <m:den>
+                        <m:r>
+                          <a:rPr lang="en-GB" sz="1600" i="1" dirty="0">
+                            <a:latin typeface="Cambria Math" panose="02040503050406030204" pitchFamily="18" charset="0"/>
+                          </a:rPr>
+                          <m:t>𝑏𝑎𝑠𝑒</m:t>
+                        </m:r>
+                        <m:r>
+                          <a:rPr lang="en-GB" sz="1600" i="1" dirty="0">
+                            <a:latin typeface="Cambria Math" panose="02040503050406030204" pitchFamily="18" charset="0"/>
+                          </a:rPr>
+                          <m:t> – 1</m:t>
+                        </m:r>
+                      </m:den>
+                    </m:f>
+                    <m:r>
+                      <a:rPr lang="en-GB" sz="1600" i="1" dirty="0">
+                        <a:latin typeface="Cambria Math" panose="02040503050406030204" pitchFamily="18" charset="0"/>
+                      </a:rPr>
+                      <m:t> ∗</m:t>
+                    </m:r>
+                    <m:r>
+                      <a:rPr lang="en-AU" sz="1600" i="1" dirty="0">
+                        <a:latin typeface="Cambria Math" panose="02040503050406030204" pitchFamily="18" charset="0"/>
+                      </a:rPr>
+                      <m:t>15 ∗</m:t>
+                    </m:r>
+                    <m:f>
+                      <m:fPr>
+                        <m:ctrlPr>
+                          <a:rPr lang="en-AU" sz="1600" i="1" dirty="0">
+                            <a:latin typeface="Cambria Math" panose="02040503050406030204" pitchFamily="18" charset="0"/>
+                          </a:rPr>
+                        </m:ctrlPr>
+                      </m:fPr>
+                      <m:num>
+                        <m:r>
+                          <a:rPr lang="en-AU" sz="1600" i="1" dirty="0">
+                            <a:latin typeface="Cambria Math" panose="02040503050406030204" pitchFamily="18" charset="0"/>
+                          </a:rPr>
+                          <m:t>𝑁𝑢𝑚𝑏𝑒𝑟𝑂𝑓𝐹𝑜𝑢𝑛𝑑𝑀𝑎𝑟𝑘𝑒𝑟𝑠</m:t>
+                        </m:r>
+                      </m:num>
+                      <m:den>
+                        <m:r>
+                          <a:rPr lang="en-AU" sz="1600" i="1" dirty="0">
+                            <a:latin typeface="Cambria Math" panose="02040503050406030204" pitchFamily="18" charset="0"/>
+                          </a:rPr>
+                          <m:t>𝑁𝑢𝑚𝑏𝑒𝑟𝑂𝑓𝑀𝑎𝑟𝑘𝑒𝑟𝑠</m:t>
+                        </m:r>
+                      </m:den>
+                    </m:f>
+                  </m:oMath>
+                </a14:m>
+                <a:r>
+                  <a:rPr lang="en-GB" sz="1600" dirty="0"/>
+                  <a:t>, base = 16</a:t>
+                </a:r>
+              </a:p>
+              <a:p>
+                <a:endParaRPr lang="en-US" sz="1600" dirty="0"/>
               </a:p>
               <a:p>
                 <a:r>
@@ -4219,12 +4441,6 @@
                   <a:rPr lang="en-US" sz="1600" dirty="0"/>
                   <a:t> ≤ 15pt): </a:t>
                 </a:r>
-              </a:p>
-              <a:p>
-                <a:endParaRPr lang="en-US" sz="1600" dirty="0"/>
-              </a:p>
-              <a:p>
-                <a:endParaRPr lang="en-US" sz="1600" dirty="0"/>
               </a:p>
               <a:p>
                 <a:r>
@@ -4261,11 +4477,7 @@
                   <a:t> </a:t>
                 </a:r>
                 <a:r>
-                  <a:rPr lang="en-GB" sz="1600" dirty="0">
-                    <a:solidFill>
-                      <a:schemeClr val="tx1"/>
-                    </a:solidFill>
-                  </a:rPr>
+                  <a:rPr lang="en-GB" sz="1600" dirty="0"/>
                   <a:t>target_accuracy_rating[object] = </a:t>
                 </a:r>
                 <a14:m>
@@ -4273,47 +4485,32 @@
                     <m:f>
                       <m:fPr>
                         <m:ctrlPr>
-                          <a:rPr lang="en-GB" sz="1600" i="1" dirty="0" smtClean="0">
-                            <a:solidFill>
-                              <a:schemeClr val="tx1"/>
-                            </a:solidFill>
+                          <a:rPr lang="en-GB" sz="1600" i="1" dirty="0">
                             <a:latin typeface="Cambria Math" panose="02040503050406030204" pitchFamily="18" charset="0"/>
                           </a:rPr>
                         </m:ctrlPr>
                       </m:fPr>
                       <m:num>
                         <m:r>
-                          <a:rPr lang="en-GB" sz="1600" i="1" dirty="0" smtClean="0">
-                            <a:solidFill>
-                              <a:schemeClr val="tx1"/>
-                            </a:solidFill>
+                          <a:rPr lang="en-GB" sz="1600" i="1" dirty="0">
                             <a:latin typeface="Cambria Math" panose="02040503050406030204" pitchFamily="18" charset="0"/>
                           </a:rPr>
                           <m:t>0.5 − </m:t>
                         </m:r>
                         <m:r>
                           <a:rPr lang="en-GB" sz="1600" i="1" dirty="0" err="1">
-                            <a:solidFill>
-                              <a:schemeClr val="tx1"/>
-                            </a:solidFill>
                             <a:latin typeface="Cambria Math" panose="02040503050406030204" pitchFamily="18" charset="0"/>
                           </a:rPr>
                           <m:t>𝑒𝑠𝑡𝑖𝑚𝑎𝑡𝑖𝑜𝑛</m:t>
                         </m:r>
                         <m:r>
-                          <a:rPr lang="en-AU" sz="1600" b="0" i="1" dirty="0" smtClean="0">
-                            <a:solidFill>
-                              <a:schemeClr val="tx1"/>
-                            </a:solidFill>
+                          <a:rPr lang="en-AU" sz="1600" i="1" dirty="0">
                             <a:latin typeface="Cambria Math" panose="02040503050406030204" pitchFamily="18" charset="0"/>
                           </a:rPr>
                           <m:t>_</m:t>
                         </m:r>
                         <m:r>
                           <a:rPr lang="en-GB" sz="1600" i="1" dirty="0" err="1">
-                            <a:solidFill>
-                              <a:schemeClr val="tx1"/>
-                            </a:solidFill>
                             <a:latin typeface="Cambria Math" panose="02040503050406030204" pitchFamily="18" charset="0"/>
                           </a:rPr>
                           <m:t>𝑒𝑟𝑟𝑜𝑟</m:t>
@@ -4324,9 +4521,6 @@
                             <m:endChr m:val="]"/>
                             <m:ctrlPr>
                               <a:rPr lang="en-GB" sz="1600" i="1" dirty="0">
-                                <a:solidFill>
-                                  <a:schemeClr val="tx1"/>
-                                </a:solidFill>
                                 <a:latin typeface="Cambria Math" panose="02040503050406030204" pitchFamily="18" charset="0"/>
                               </a:rPr>
                             </m:ctrlPr>
@@ -4334,9 +4528,6 @@
                           <m:e>
                             <m:r>
                               <a:rPr lang="en-GB" sz="1600" i="1" dirty="0">
-                                <a:solidFill>
-                                  <a:schemeClr val="tx1"/>
-                                </a:solidFill>
                                 <a:latin typeface="Cambria Math" panose="02040503050406030204" pitchFamily="18" charset="0"/>
                               </a:rPr>
                               <m:t>𝑜𝑏𝑗𝑒𝑐𝑡</m:t>
@@ -4347,9 +4538,6 @@
                       <m:den>
                         <m:r>
                           <a:rPr lang="en-GB" sz="1600" i="1" dirty="0">
-                            <a:solidFill>
-                              <a:schemeClr val="tx1"/>
-                            </a:solidFill>
                             <a:latin typeface="Cambria Math" panose="02040503050406030204" pitchFamily="18" charset="0"/>
                           </a:rPr>
                           <m:t>0.5−0.025</m:t>
@@ -4357,10 +4545,7 @@
                       </m:den>
                     </m:f>
                     <m:r>
-                      <a:rPr lang="en-GB" sz="1600" i="1" dirty="0" smtClean="0">
-                        <a:solidFill>
-                          <a:schemeClr val="tx1"/>
-                        </a:solidFill>
+                      <a:rPr lang="en-GB" sz="1600" i="1" dirty="0">
                         <a:latin typeface="Cambria Math" panose="02040503050406030204" pitchFamily="18" charset="0"/>
                       </a:rPr>
                       <m:t> </m:t>
@@ -4368,11 +4553,7 @@
                   </m:oMath>
                 </a14:m>
                 <a:r>
-                  <a:rPr lang="en-GB" sz="1600" dirty="0">
-                    <a:solidFill>
-                      <a:schemeClr val="tx1"/>
-                    </a:solidFill>
-                  </a:rPr>
+                  <a:rPr lang="en-GB" sz="1600" dirty="0"/>
                   <a:t>= TAR</a:t>
                 </a:r>
                 <a:r>
@@ -4387,19 +4568,11 @@
               <a:p>
                 <a:pPr algn="ctr"/>
                 <a:r>
-                  <a:rPr lang="en-GB" sz="1600" dirty="0" err="1">
-                    <a:solidFill>
-                      <a:schemeClr val="tx1"/>
-                    </a:solidFill>
-                  </a:rPr>
+                  <a:rPr lang="en-GB" sz="1600" dirty="0" err="1"/>
                   <a:t>target_est_score</a:t>
                 </a:r>
                 <a:r>
-                  <a:rPr lang="en-GB" sz="1600" dirty="0">
-                    <a:solidFill>
-                      <a:schemeClr val="tx1"/>
-                    </a:solidFill>
-                  </a:rPr>
+                  <a:rPr lang="en-GB" sz="1600" dirty="0"/>
                   <a:t> = </a:t>
                 </a:r>
                 <a14:m>
@@ -4408,9 +4581,6 @@
                       <m:fPr>
                         <m:ctrlPr>
                           <a:rPr lang="en-GB" sz="1600" i="1" dirty="0">
-                            <a:solidFill>
-                              <a:schemeClr val="tx1"/>
-                            </a:solidFill>
                             <a:latin typeface="Cambria Math" panose="02040503050406030204" pitchFamily="18" charset="0"/>
                           </a:rPr>
                         </m:ctrlPr>
@@ -4418,9 +4588,6 @@
                       <m:num>
                         <m:r>
                           <a:rPr lang="en-GB" sz="1600" i="1" dirty="0" err="1">
-                            <a:solidFill>
-                              <a:schemeClr val="tx1"/>
-                            </a:solidFill>
                             <a:latin typeface="Cambria Math" panose="02040503050406030204" pitchFamily="18" charset="0"/>
                           </a:rPr>
                           <m:t>𝑏𝑎𝑠</m:t>
@@ -4429,9 +4596,6 @@
                           <m:sSupPr>
                             <m:ctrlPr>
                               <a:rPr lang="en-GB" sz="1600" i="1" dirty="0" err="1">
-                                <a:solidFill>
-                                  <a:schemeClr val="tx1"/>
-                                </a:solidFill>
                                 <a:latin typeface="Cambria Math" panose="02040503050406030204" pitchFamily="18" charset="0"/>
                               </a:rPr>
                             </m:ctrlPr>
@@ -4439,9 +4603,6 @@
                           <m:e>
                             <m:r>
                               <a:rPr lang="en-GB" sz="1600" i="1" dirty="0" err="1">
-                                <a:solidFill>
-                                  <a:schemeClr val="tx1"/>
-                                </a:solidFill>
                                 <a:latin typeface="Cambria Math" panose="02040503050406030204" pitchFamily="18" charset="0"/>
                               </a:rPr>
                               <m:t>𝑒</m:t>
@@ -4450,9 +4611,6 @@
                           <m:sup>
                             <m:r>
                               <a:rPr lang="en-GB" sz="1600" i="1" dirty="0" err="1">
-                                <a:solidFill>
-                                  <a:schemeClr val="tx1"/>
-                                </a:solidFill>
                                 <a:latin typeface="Cambria Math" panose="02040503050406030204" pitchFamily="18" charset="0"/>
                               </a:rPr>
                               <m:t>𝑚𝑒𝑎𝑛</m:t>
@@ -4461,9 +4619,6 @@
                               <m:dPr>
                                 <m:ctrlPr>
                                   <a:rPr lang="en-GB" sz="1600" i="1" dirty="0">
-                                    <a:solidFill>
-                                      <a:schemeClr val="tx1"/>
-                                    </a:solidFill>
                                     <a:latin typeface="Cambria Math" panose="02040503050406030204" pitchFamily="18" charset="0"/>
                                   </a:rPr>
                                 </m:ctrlPr>
@@ -4471,9 +4626,6 @@
                               <m:e>
                                 <m:r>
                                   <a:rPr lang="en-GB" sz="1600" i="1" dirty="0">
-                                    <a:solidFill>
-                                      <a:schemeClr val="tx1"/>
-                                    </a:solidFill>
                                     <a:latin typeface="Cambria Math" panose="02040503050406030204" pitchFamily="18" charset="0"/>
                                   </a:rPr>
                                   <m:t>𝑇𝐴𝑅</m:t>
@@ -4484,9 +4636,6 @@
                         </m:sSup>
                         <m:r>
                           <a:rPr lang="en-GB" sz="1600" i="1" dirty="0">
-                            <a:solidFill>
-                              <a:schemeClr val="tx1"/>
-                            </a:solidFill>
                             <a:latin typeface="Cambria Math" panose="02040503050406030204" pitchFamily="18" charset="0"/>
                           </a:rPr>
                           <m:t>– 1</m:t>
@@ -4495,18 +4644,12 @@
                       <m:den>
                         <m:r>
                           <a:rPr lang="en-GB" sz="1600" i="1" dirty="0">
-                            <a:solidFill>
-                              <a:schemeClr val="tx1"/>
-                            </a:solidFill>
                             <a:latin typeface="Cambria Math" panose="02040503050406030204" pitchFamily="18" charset="0"/>
                           </a:rPr>
                           <m:t>𝑏𝑎𝑠𝑒</m:t>
                         </m:r>
                         <m:r>
                           <a:rPr lang="en-GB" sz="1600" i="1" dirty="0">
-                            <a:solidFill>
-                              <a:schemeClr val="tx1"/>
-                            </a:solidFill>
                             <a:latin typeface="Cambria Math" panose="02040503050406030204" pitchFamily="18" charset="0"/>
                           </a:rPr>
                           <m:t> – 1</m:t>
@@ -4515,18 +4658,12 @@
                     </m:f>
                     <m:r>
                       <a:rPr lang="en-GB" sz="1600" i="1" dirty="0">
-                        <a:solidFill>
-                          <a:schemeClr val="tx1"/>
-                        </a:solidFill>
                         <a:latin typeface="Cambria Math" panose="02040503050406030204" pitchFamily="18" charset="0"/>
                       </a:rPr>
                       <m:t> ∗</m:t>
                     </m:r>
                     <m:r>
-                      <a:rPr lang="en-AU" sz="1600" b="0" i="1" dirty="0" smtClean="0">
-                        <a:solidFill>
-                          <a:schemeClr val="tx1"/>
-                        </a:solidFill>
+                      <a:rPr lang="en-AU" sz="1600" i="1" dirty="0">
                         <a:latin typeface="Cambria Math" panose="02040503050406030204" pitchFamily="18" charset="0"/>
                       </a:rPr>
                       <m:t>15</m:t>
@@ -4534,125 +4671,73 @@
                   </m:oMath>
                 </a14:m>
                 <a:r>
-                  <a:rPr lang="en-GB" sz="1600" dirty="0">
-                    <a:solidFill>
-                      <a:schemeClr val="tx1"/>
-                    </a:solidFill>
-                  </a:rPr>
+                  <a:rPr lang="en-GB" sz="1600" dirty="0"/>
                   <a:t>, base = 8</a:t>
                 </a:r>
               </a:p>
               <a:p>
                 <a:pPr algn="ctr"/>
-                <a:endParaRPr lang="en-GB" sz="1600" dirty="0">
-                  <a:solidFill>
-                    <a:schemeClr val="tx1"/>
-                  </a:solidFill>
-                </a:endParaRPr>
+                <a:endParaRPr lang="en-GB" sz="1600" dirty="0"/>
               </a:p>
               <a:p>
                 <a:r>
-                  <a:rPr lang="en-GB" sz="1600" dirty="0">
-                    <a:solidFill>
-                      <a:schemeClr val="tx1"/>
-                    </a:solidFill>
-                  </a:rPr>
-                  <a:t>Example submission folder structure format (Please read the marking instructions </a:t>
+                  <a:rPr lang="en-GB" sz="1600" dirty="0"/>
+                  <a:t>Example submission folder structure format (Please read the marking instructions carefully for this!):</a:t>
                 </a:r>
-                <a:r>
-                  <a:rPr lang="en-GB" sz="1600">
-                    <a:solidFill>
-                      <a:schemeClr val="tx1"/>
-                    </a:solidFill>
-                  </a:rPr>
-                  <a:t>carefully for this!):</a:t>
-                </a:r>
-                <a:endParaRPr lang="en-GB" sz="1600" dirty="0">
-                  <a:solidFill>
-                    <a:schemeClr val="tx1"/>
-                  </a:solidFill>
-                </a:endParaRPr>
               </a:p>
               <a:p>
                 <a:r>
-                  <a:rPr lang="en-AU" dirty="0"/>
+                  <a:rPr lang="en-AU" sz="1600" dirty="0"/>
                   <a:t>.</a:t>
                 </a:r>
               </a:p>
               <a:p>
                 <a:r>
-                  <a:rPr lang="en-AU" dirty="0"/>
+                  <a:rPr lang="en-AU" sz="1600" dirty="0"/>
                   <a:t>├── C2_Team_X0</a:t>
                 </a:r>
               </a:p>
               <a:p>
                 <a:r>
-                  <a:rPr lang="en-AU" dirty="0"/>
+                  <a:rPr lang="en-AU" sz="1600" dirty="0"/>
                   <a:t>│   ├── slam_auto_4.txt</a:t>
                 </a:r>
               </a:p>
               <a:p>
                 <a:r>
-                  <a:rPr lang="en-AU" dirty="0"/>
+                  <a:rPr lang="en-AU" sz="1600" dirty="0"/>
                   <a:t>│   ├── slam_manual_1.txt</a:t>
                 </a:r>
               </a:p>
               <a:p>
                 <a:r>
-                  <a:rPr lang="en-AU" dirty="0"/>
+                  <a:rPr lang="en-AU" sz="1600" dirty="0"/>
                   <a:t>│   ├── slam_manual_2.txt</a:t>
                 </a:r>
               </a:p>
               <a:p>
                 <a:r>
-                  <a:rPr lang="en-AU" dirty="0"/>
+                  <a:rPr lang="en-AU" sz="1600" dirty="0"/>
                   <a:t>│   ├── targets_auto_4.txt</a:t>
                 </a:r>
               </a:p>
               <a:p>
                 <a:r>
-                  <a:rPr lang="en-AU" dirty="0"/>
+                  <a:rPr lang="en-AU" sz="1600" dirty="0"/>
                   <a:t>│   ├── targets_manual_1.txt </a:t>
                 </a:r>
               </a:p>
               <a:p>
                 <a:r>
-                  <a:rPr lang="en-AU" dirty="0"/>
+                  <a:rPr lang="en-AU" sz="1600" dirty="0"/>
                   <a:t>│   ├── targets_manual_2.txt </a:t>
                 </a:r>
-              </a:p>
-              <a:p>
-                <a:endParaRPr lang="en-GB" sz="1400" dirty="0"/>
-              </a:p>
-              <a:p>
-                <a:br>
-                  <a:rPr lang="en-GB" dirty="0"/>
-                </a:br>
-                <a:endParaRPr lang="en-GB" dirty="0"/>
-              </a:p>
-              <a:p>
-                <a:pPr algn="ctr"/>
-                <a:endParaRPr lang="en-GB" sz="1600" dirty="0">
-                  <a:solidFill>
-                    <a:schemeClr val="tx1"/>
-                  </a:solidFill>
-                </a:endParaRPr>
-              </a:p>
-              <a:p>
-                <a:pPr algn="ctr"/>
-                <a:endParaRPr lang="en-US" sz="1600" dirty="0">
-                  <a:solidFill>
-                    <a:schemeClr val="tx1"/>
-                  </a:solidFill>
-                </a:endParaRPr>
-              </a:p>
-              <a:p>
                 <a:endParaRPr lang="en-US" sz="1600" dirty="0"/>
               </a:p>
             </p:txBody>
           </p:sp>
         </mc:Choice>
-        <mc:Fallback xmlns="">
+        <mc:Fallback>
           <p:sp>
             <p:nvSpPr>
               <p:cNvPr id="5" name="TextBox 4">
@@ -4670,7 +4755,7 @@
             <p:spPr>
               <a:xfrm>
                 <a:off x="478180" y="838376"/>
-                <a:ext cx="11588314" cy="7365093"/>
+                <a:ext cx="11588314" cy="5580630"/>
               </a:xfrm>
               <a:prstGeom prst="rect">
                 <a:avLst/>
@@ -4678,7 +4763,7 @@
               <a:blipFill>
                 <a:blip r:embed="rId2"/>
                 <a:stretch>
-                  <a:fillRect l="-421"/>
+                  <a:fillRect l="-263" b="-437"/>
                 </a:stretch>
               </a:blipFill>
             </p:spPr>

</xml_diff>